<commit_message>
Refaz a apresentacao com 4 slides, capa, introducao, projeto e valores
Acrescenta capa com o gradiente e a textura diagonal do arquivo modelo, e slide
de introducao com quem e a Nunes & Lucato e o fluxo em quatro etapas.

O slide do projeto agora traz o logotipo da Leroy Merlin, a grade completa de
tamanhos das duas pecas e a materia-prima apurada em metros e em pecas
equivalentes.

Resolve a repeticao de imagem, cada slide passa a ter um tratamento proprio.
A capa usa a ecobag em monocromia azul, a introducao a foto da necessaire, o
slide do projeto um mockup novo dos dois produtos em cena de estudio e o slide
de valores dispensa foto.

Inclui build_mockup.py, que recorta os produtos com GrabCut e compoe a cena com
sombra de contato. Corrige tambem um erro de digitacao em texteis e passa os
paragrafos a quebrar na largura disponivel, que antes invadiam a coluna da foto.
</commit_message>
<xml_diff>
--- a/leroy-merlin-apresentacao/slides-projeto-leroy-merlin.pptx
+++ b/leroy-merlin-apresentacao/slides-projeto-leroy-merlin.pptx
@@ -7,6 +7,8 @@
   <p:sldIdLst>
     <p:sldId id="256" r:id="rId7"/>
     <p:sldId id="257" r:id="rId8"/>
+    <p:sldId id="258" r:id="rId9"/>
+    <p:sldId id="259" r:id="rId10"/>
   </p:sldIdLst>
   <p:sldSz cx="18288000" cy="10287000" type="screen4x3"/>
   <p:notesSz cx="6858000" cy="9144000"/>
@@ -3091,7 +3093,7 @@
       <p:grpSpPr/>
       <p:pic>
         <p:nvPicPr>
-          <p:cNvPr id="2" name="Picture 1" descr="alta12.jpg"/>
+          <p:cNvPr id="2" name="Picture 1" descr="alta1.jpg"/>
           <p:cNvPicPr>
             <a:picLocks noChangeAspect="1"/>
           </p:cNvPicPr>
@@ -3133,7 +3135,91 @@
       <p:grpSpPr/>
       <p:pic>
         <p:nvPicPr>
-          <p:cNvPr id="2" name="Picture 1" descr="alta13.jpg"/>
+          <p:cNvPr id="2" name="Picture 1" descr="alta2.jpg"/>
+          <p:cNvPicPr>
+            <a:picLocks noChangeAspect="1"/>
+          </p:cNvPicPr>
+          <p:nvPr/>
+        </p:nvPicPr>
+        <p:blipFill>
+          <a:blip r:embed="rId2"/>
+          <a:stretch>
+            <a:fillRect/>
+          </a:stretch>
+        </p:blipFill>
+        <p:spPr>
+          <a:xfrm>
+            <a:off x="0" y="0"/>
+            <a:ext cx="18288000" cy="10287000"/>
+          </a:xfrm>
+          <a:prstGeom prst="rect">
+            <a:avLst/>
+          </a:prstGeom>
+        </p:spPr>
+      </p:pic>
+    </p:spTree>
+  </p:cSld>
+  <p:clrMapOvr>
+    <a:masterClrMapping/>
+  </p:clrMapOvr>
+</p:sld>
+</file>
+
+<file path=ppt/slides/slide3.xml><?xml version="1.0" encoding="utf-8"?>
+<p:sld xmlns:a="http://schemas.openxmlformats.org/drawingml/2006/main" xmlns:p="http://schemas.openxmlformats.org/presentationml/2006/main" xmlns:r="http://schemas.openxmlformats.org/officeDocument/2006/relationships">
+  <p:cSld>
+    <p:spTree>
+      <p:nvGrpSpPr>
+        <p:cNvPr id="1" name=""/>
+        <p:cNvGrpSpPr/>
+        <p:nvPr/>
+      </p:nvGrpSpPr>
+      <p:grpSpPr/>
+      <p:pic>
+        <p:nvPicPr>
+          <p:cNvPr id="2" name="Picture 1" descr="alta3.jpg"/>
+          <p:cNvPicPr>
+            <a:picLocks noChangeAspect="1"/>
+          </p:cNvPicPr>
+          <p:nvPr/>
+        </p:nvPicPr>
+        <p:blipFill>
+          <a:blip r:embed="rId2"/>
+          <a:stretch>
+            <a:fillRect/>
+          </a:stretch>
+        </p:blipFill>
+        <p:spPr>
+          <a:xfrm>
+            <a:off x="0" y="0"/>
+            <a:ext cx="18288000" cy="10287000"/>
+          </a:xfrm>
+          <a:prstGeom prst="rect">
+            <a:avLst/>
+          </a:prstGeom>
+        </p:spPr>
+      </p:pic>
+    </p:spTree>
+  </p:cSld>
+  <p:clrMapOvr>
+    <a:masterClrMapping/>
+  </p:clrMapOvr>
+</p:sld>
+</file>
+
+<file path=ppt/slides/slide4.xml><?xml version="1.0" encoding="utf-8"?>
+<p:sld xmlns:a="http://schemas.openxmlformats.org/drawingml/2006/main" xmlns:p="http://schemas.openxmlformats.org/presentationml/2006/main" xmlns:r="http://schemas.openxmlformats.org/officeDocument/2006/relationships">
+  <p:cSld>
+    <p:spTree>
+      <p:nvGrpSpPr>
+        <p:cNvPr id="1" name=""/>
+        <p:cNvGrpSpPr/>
+        <p:nvPr/>
+      </p:nvGrpSpPr>
+      <p:grpSpPr/>
+      <p:pic>
+        <p:nvPicPr>
+          <p:cNvPr id="2" name="Picture 1" descr="alta4.jpg"/>
           <p:cNvPicPr>
             <a:picLocks noChangeAspect="1"/>
           </p:cNvPicPr>

</xml_diff>